<commit_message>
docs: aprimorar visual das apresentacoes
</commit_message>
<xml_diff>
--- a/docs/apresentacoes/Bonanca_Arquitetura_e_Importacao_de_Dados.pptx
+++ b/docs/apresentacoes/Bonanca_Arquitetura_e_Importacao_de_Dados.pptx
@@ -1656,12 +1656,17 @@
         </p:nvSpPr>
         <p:spPr>
           <a:xfrm>
-            <a:off x="1219200" y="6997700"/>
-            <a:ext cx="13817600" cy="9144"/>
-          </a:xfrm>
-          <a:prstGeom prst="line">
-            <a:avLst/>
-          </a:prstGeom>
+            <a:off x="1219200" y="6248400"/>
+            <a:ext cx="1905000" cy="406400"/>
+          </a:xfrm>
+          <a:prstGeom prst="rect">
+            <a:avLst/>
+          </a:prstGeom>
+          <a:solidFill>
+            <a:srgbClr val="F9F8F4">
+              <a:alpha val="8000"/>
+            </a:srgbClr>
+          </a:solidFill>
           <a:ln w="12700">
             <a:solidFill>
               <a:srgbClr val="F9F8F4">
@@ -1674,7 +1679,206 @@
       </p:sp>
       <p:sp>
         <p:nvSpPr>
-          <p:cNvPr id="7" name="footer"/>
+          <p:cNvPr id="7" name="capa-text-6"/>
+          <p:cNvSpPr/>
+          <p:nvPr/>
+        </p:nvSpPr>
+        <p:spPr>
+          <a:xfrm>
+            <a:off x="1371600" y="6362700"/>
+            <a:ext cx="1600200" cy="177800"/>
+          </a:xfrm>
+          <a:prstGeom prst="rect">
+            <a:avLst/>
+          </a:prstGeom>
+          <a:noFill/>
+          <a:ln/>
+        </p:spPr>
+        <p:txBody>
+          <a:bodyPr wrap="none" lIns="0" tIns="0" rIns="0" bIns="0" rtlCol="0" anchor="t"/>
+          <a:lstStyle/>
+          <a:p>
+            <a:pPr algn="ctr" indent="0" marL="0">
+              <a:buNone/>
+            </a:pPr>
+            <a:r>
+              <a:rPr lang="en-US" altLang="en-US" sz="1200" dirty="0">
+                <a:solidFill>
+                  <a:srgbClr val="F9F8F4"/>
+                </a:solidFill>
+                <a:latin typeface="Inter" pitchFamily="34" charset="0"/>
+                <a:ea typeface="Inter" pitchFamily="34" charset="-122"/>
+                <a:cs typeface="Inter" pitchFamily="34" charset="-120"/>
+              </a:rPr>
+              <a:t>ORIGEM</a:t>
+            </a:r>
+            <a:endParaRPr lang="en-US" sz="1200" dirty="0"/>
+          </a:p>
+        </p:txBody>
+      </p:sp>
+      <p:sp>
+        <p:nvSpPr>
+          <p:cNvPr id="8" name="capa-shape-7"/>
+          <p:cNvSpPr/>
+          <p:nvPr/>
+        </p:nvSpPr>
+        <p:spPr>
+          <a:xfrm>
+            <a:off x="3276600" y="6248400"/>
+            <a:ext cx="1905000" cy="406400"/>
+          </a:xfrm>
+          <a:prstGeom prst="rect">
+            <a:avLst/>
+          </a:prstGeom>
+          <a:solidFill>
+            <a:srgbClr val="F9F8F4">
+              <a:alpha val="8000"/>
+            </a:srgbClr>
+          </a:solidFill>
+          <a:ln w="12700">
+            <a:solidFill>
+              <a:srgbClr val="F9F8F4">
+                <a:alpha val="50000"/>
+              </a:srgbClr>
+            </a:solidFill>
+            <a:prstDash val="solid"/>
+          </a:ln>
+        </p:spPr>
+      </p:sp>
+      <p:sp>
+        <p:nvSpPr>
+          <p:cNvPr id="9" name="capa-text-8"/>
+          <p:cNvSpPr/>
+          <p:nvPr/>
+        </p:nvSpPr>
+        <p:spPr>
+          <a:xfrm>
+            <a:off x="3429000" y="6362700"/>
+            <a:ext cx="1600200" cy="177800"/>
+          </a:xfrm>
+          <a:prstGeom prst="rect">
+            <a:avLst/>
+          </a:prstGeom>
+          <a:noFill/>
+          <a:ln/>
+        </p:spPr>
+        <p:txBody>
+          <a:bodyPr wrap="none" lIns="0" tIns="0" rIns="0" bIns="0" rtlCol="0" anchor="t"/>
+          <a:lstStyle/>
+          <a:p>
+            <a:pPr algn="ctr" indent="0" marL="0">
+              <a:buNone/>
+            </a:pPr>
+            <a:r>
+              <a:rPr lang="en-US" altLang="en-US" sz="1200" dirty="0">
+                <a:solidFill>
+                  <a:srgbClr val="F9F8F4"/>
+                </a:solidFill>
+                <a:latin typeface="Inter" pitchFamily="34" charset="0"/>
+                <a:ea typeface="Inter" pitchFamily="34" charset="-122"/>
+                <a:cs typeface="Inter" pitchFamily="34" charset="-120"/>
+              </a:rPr>
+              <a:t>GOVERNANÇA</a:t>
+            </a:r>
+            <a:endParaRPr lang="en-US" sz="1200" dirty="0"/>
+          </a:p>
+        </p:txBody>
+      </p:sp>
+      <p:sp>
+        <p:nvSpPr>
+          <p:cNvPr id="10" name="capa-shape-9"/>
+          <p:cNvSpPr/>
+          <p:nvPr/>
+        </p:nvSpPr>
+        <p:spPr>
+          <a:xfrm>
+            <a:off x="5334000" y="6248400"/>
+            <a:ext cx="1905000" cy="406400"/>
+          </a:xfrm>
+          <a:prstGeom prst="rect">
+            <a:avLst/>
+          </a:prstGeom>
+          <a:solidFill>
+            <a:srgbClr val="F9F8F4">
+              <a:alpha val="8000"/>
+            </a:srgbClr>
+          </a:solidFill>
+          <a:ln w="12700">
+            <a:solidFill>
+              <a:srgbClr val="F9F8F4">
+                <a:alpha val="50000"/>
+              </a:srgbClr>
+            </a:solidFill>
+            <a:prstDash val="solid"/>
+          </a:ln>
+        </p:spPr>
+      </p:sp>
+      <p:sp>
+        <p:nvSpPr>
+          <p:cNvPr id="11" name="capa-text-10"/>
+          <p:cNvSpPr/>
+          <p:nvPr/>
+        </p:nvSpPr>
+        <p:spPr>
+          <a:xfrm>
+            <a:off x="5486400" y="6362700"/>
+            <a:ext cx="1600200" cy="177800"/>
+          </a:xfrm>
+          <a:prstGeom prst="rect">
+            <a:avLst/>
+          </a:prstGeom>
+          <a:noFill/>
+          <a:ln/>
+        </p:spPr>
+        <p:txBody>
+          <a:bodyPr wrap="none" lIns="0" tIns="0" rIns="0" bIns="0" rtlCol="0" anchor="t"/>
+          <a:lstStyle/>
+          <a:p>
+            <a:pPr algn="ctr" indent="0" marL="0">
+              <a:buNone/>
+            </a:pPr>
+            <a:r>
+              <a:rPr lang="en-US" altLang="en-US" sz="1200" dirty="0">
+                <a:solidFill>
+                  <a:srgbClr val="F9F8F4"/>
+                </a:solidFill>
+                <a:latin typeface="Inter" pitchFamily="34" charset="0"/>
+                <a:ea typeface="Inter" pitchFamily="34" charset="-122"/>
+                <a:cs typeface="Inter" pitchFamily="34" charset="-120"/>
+              </a:rPr>
+              <a:t>DECISÃO</a:t>
+            </a:r>
+            <a:endParaRPr lang="en-US" sz="1200" dirty="0"/>
+          </a:p>
+        </p:txBody>
+      </p:sp>
+      <p:sp>
+        <p:nvSpPr>
+          <p:cNvPr id="12" name="capa-shape-11"/>
+          <p:cNvSpPr/>
+          <p:nvPr/>
+        </p:nvSpPr>
+        <p:spPr>
+          <a:xfrm>
+            <a:off x="1219200" y="6997700"/>
+            <a:ext cx="13817600" cy="9144"/>
+          </a:xfrm>
+          <a:prstGeom prst="line">
+            <a:avLst/>
+          </a:prstGeom>
+          <a:ln w="12700">
+            <a:solidFill>
+              <a:srgbClr val="F9F8F4">
+                <a:alpha val="50000"/>
+              </a:srgbClr>
+            </a:solidFill>
+            <a:prstDash val="solid"/>
+          </a:ln>
+        </p:spPr>
+      </p:sp>
+      <p:sp>
+        <p:nvSpPr>
+          <p:cNvPr id="13" name="footer"/>
           <p:cNvSpPr/>
           <p:nvPr/>
         </p:nvSpPr>
@@ -1711,9 +1915,48 @@
           </a:p>
         </p:txBody>
       </p:sp>
+      <p:sp>
+        <p:nvSpPr>
+          <p:cNvPr id="14" name="capa-text-13"/>
+          <p:cNvSpPr/>
+          <p:nvPr/>
+        </p:nvSpPr>
+        <p:spPr>
+          <a:xfrm>
+            <a:off x="11811000" y="7366000"/>
+            <a:ext cx="2921000" cy="355600"/>
+          </a:xfrm>
+          <a:prstGeom prst="rect">
+            <a:avLst/>
+          </a:prstGeom>
+          <a:noFill/>
+          <a:ln/>
+        </p:spPr>
+        <p:txBody>
+          <a:bodyPr wrap="square" lIns="0" tIns="0" rIns="0" bIns="0" rtlCol="0" anchor="t"/>
+          <a:lstStyle/>
+          <a:p>
+            <a:pPr algn="r" indent="0" marL="0">
+              <a:buNone/>
+            </a:pPr>
+            <a:r>
+              <a:rPr lang="en-US" altLang="en-US" sz="1600" dirty="0">
+                <a:solidFill>
+                  <a:srgbClr val="F9F8F4"/>
+                </a:solidFill>
+                <a:latin typeface="Inter" pitchFamily="34" charset="0"/>
+                <a:ea typeface="Inter" pitchFamily="34" charset="-122"/>
+                <a:cs typeface="Inter" pitchFamily="34" charset="-120"/>
+              </a:rPr>
+              <a:t>BONANÇA DATA CORE</a:t>
+            </a:r>
+            <a:endParaRPr lang="en-US" sz="1600" dirty="0"/>
+          </a:p>
+        </p:txBody>
+      </p:sp>
       <p:pic>
         <p:nvPicPr>
-          <p:cNvPr id="8" name="capa-icon-7" descr="preencoded.png">    </p:cNvPr>
+          <p:cNvPr id="15" name="capa-icon-14" descr="preencoded.png">    </p:cNvPr>
           <p:cNvPicPr>
             <a:picLocks noChangeAspect="1"/>
           </p:cNvPicPr>
@@ -1739,7 +1982,7 @@
       </p:pic>
       <p:pic>
         <p:nvPicPr>
-          <p:cNvPr id="9" name="capa-icon-8" descr="preencoded.png">    </p:cNvPr>
+          <p:cNvPr id="16" name="capa-icon-15" descr="preencoded.png">    </p:cNvPr>
           <p:cNvPicPr>
             <a:picLocks noChangeAspect="1"/>
           </p:cNvPicPr>
@@ -1765,7 +2008,7 @@
       </p:pic>
       <p:pic>
         <p:nvPicPr>
-          <p:cNvPr id="10" name="capa-icon-9" descr="preencoded.png">    </p:cNvPr>
+          <p:cNvPr id="17" name="capa-icon-16" descr="preencoded.png">    </p:cNvPr>
           <p:cNvPicPr>
             <a:picLocks noChangeAspect="1"/>
           </p:cNvPicPr>
@@ -1966,6 +2209,65 @@
         </p:nvSpPr>
         <p:spPr>
           <a:xfrm>
+            <a:off x="4953000" y="3429000"/>
+            <a:ext cx="1651000" cy="330200"/>
+          </a:xfrm>
+          <a:prstGeom prst="rect">
+            <a:avLst/>
+          </a:prstGeom>
+          <a:solidFill>
+            <a:srgbClr val="1C5D6C"/>
+          </a:solidFill>
+          <a:ln/>
+        </p:spPr>
+      </p:sp>
+      <p:sp>
+        <p:nvSpPr>
+          <p:cNvPr id="7" name="visao-text-6"/>
+          <p:cNvSpPr/>
+          <p:nvPr/>
+        </p:nvSpPr>
+        <p:spPr>
+          <a:xfrm>
+            <a:off x="5080000" y="3517900"/>
+            <a:ext cx="1397000" cy="152400"/>
+          </a:xfrm>
+          <a:prstGeom prst="rect">
+            <a:avLst/>
+          </a:prstGeom>
+          <a:noFill/>
+          <a:ln/>
+        </p:spPr>
+        <p:txBody>
+          <a:bodyPr wrap="none" lIns="0" tIns="0" rIns="0" bIns="0" rtlCol="0" anchor="t"/>
+          <a:lstStyle/>
+          <a:p>
+            <a:pPr algn="ctr" indent="0" marL="0">
+              <a:buNone/>
+            </a:pPr>
+            <a:r>
+              <a:rPr lang="en-US" altLang="en-US" sz="1100" dirty="0">
+                <a:solidFill>
+                  <a:srgbClr val="F9F8F4"/>
+                </a:solidFill>
+                <a:latin typeface="Inter" pitchFamily="34" charset="0"/>
+                <a:ea typeface="Inter" pitchFamily="34" charset="-122"/>
+                <a:cs typeface="Inter" pitchFamily="34" charset="-120"/>
+              </a:rPr>
+              <a:t>EXPANSÍVEL</a:t>
+            </a:r>
+            <a:endParaRPr lang="en-US" sz="1100" dirty="0"/>
+          </a:p>
+        </p:txBody>
+      </p:sp>
+      <p:sp>
+        <p:nvSpPr>
+          <p:cNvPr id="8" name="visao-shape-7"/>
+          <p:cNvSpPr/>
+          <p:nvPr/>
+        </p:nvSpPr>
+        <p:spPr>
+          <a:xfrm>
             <a:off x="508000" y="4089400"/>
             <a:ext cx="6096000" cy="1270000"/>
           </a:xfrm>
@@ -1985,7 +2287,7 @@
       </p:sp>
       <p:pic>
         <p:nvPicPr>
-          <p:cNvPr id="7" name="visao-icon-6" descr="preencoded.png">    </p:cNvPr>
+          <p:cNvPr id="9" name="visao-icon-8" descr="preencoded.png">    </p:cNvPr>
           <p:cNvPicPr>
             <a:picLocks noChangeAspect="1"/>
           </p:cNvPicPr>
@@ -2009,7 +2311,7 @@
       </p:pic>
       <p:sp>
         <p:nvSpPr>
-          <p:cNvPr id="8" name="visao-text-7"/>
+          <p:cNvPr id="10" name="visao-text-9"/>
           <p:cNvSpPr/>
           <p:nvPr/>
         </p:nvSpPr>
@@ -2065,7 +2367,7 @@
       </p:sp>
       <p:sp>
         <p:nvSpPr>
-          <p:cNvPr id="9" name="visao-shape-8"/>
+          <p:cNvPr id="11" name="visao-shape-10"/>
           <p:cNvSpPr/>
           <p:nvPr/>
         </p:nvSpPr>
@@ -2090,7 +2392,7 @@
       </p:sp>
       <p:pic>
         <p:nvPicPr>
-          <p:cNvPr id="10" name="visao-icon-9" descr="preencoded.png">    </p:cNvPr>
+          <p:cNvPr id="12" name="visao-icon-11" descr="preencoded.png">    </p:cNvPr>
           <p:cNvPicPr>
             <a:picLocks noChangeAspect="1"/>
           </p:cNvPicPr>
@@ -2114,7 +2416,7 @@
       </p:pic>
       <p:sp>
         <p:nvSpPr>
-          <p:cNvPr id="11" name="visao-text-10"/>
+          <p:cNvPr id="13" name="visao-text-12"/>
           <p:cNvSpPr/>
           <p:nvPr/>
         </p:nvSpPr>
@@ -2170,7 +2472,7 @@
       </p:sp>
       <p:sp>
         <p:nvSpPr>
-          <p:cNvPr id="12" name="visao-shape-11"/>
+          <p:cNvPr id="14" name="visao-shape-13"/>
           <p:cNvSpPr/>
           <p:nvPr/>
         </p:nvSpPr>
@@ -2195,7 +2497,7 @@
       </p:sp>
       <p:pic>
         <p:nvPicPr>
-          <p:cNvPr id="13" name="visao-icon-12" descr="preencoded.png">    </p:cNvPr>
+          <p:cNvPr id="15" name="visao-icon-14" descr="preencoded.png">    </p:cNvPr>
           <p:cNvPicPr>
             <a:picLocks noChangeAspect="1"/>
           </p:cNvPicPr>
@@ -2219,7 +2521,7 @@
       </p:pic>
       <p:sp>
         <p:nvSpPr>
-          <p:cNvPr id="14" name="visao-text-13"/>
+          <p:cNvPr id="16" name="visao-text-15"/>
           <p:cNvSpPr/>
           <p:nvPr/>
         </p:nvSpPr>
@@ -2275,7 +2577,7 @@
       </p:sp>
       <p:sp>
         <p:nvSpPr>
-          <p:cNvPr id="15" name="visao-shape-14"/>
+          <p:cNvPr id="17" name="visao-shape-16"/>
           <p:cNvSpPr/>
           <p:nvPr/>
         </p:nvSpPr>
@@ -2295,7 +2597,7 @@
       </p:sp>
       <p:sp>
         <p:nvSpPr>
-          <p:cNvPr id="16" name="visao-text-15"/>
+          <p:cNvPr id="18" name="visao-text-17"/>
           <p:cNvSpPr/>
           <p:nvPr/>
         </p:nvSpPr>
@@ -2334,7 +2636,46 @@
       </p:sp>
       <p:sp>
         <p:nvSpPr>
-          <p:cNvPr id="17" name="visao-shape-16"/>
+          <p:cNvPr id="19" name="visao-text-18"/>
+          <p:cNvSpPr/>
+          <p:nvPr/>
+        </p:nvSpPr>
+        <p:spPr>
+          <a:xfrm>
+            <a:off x="9461500" y="3632200"/>
+            <a:ext cx="3175000" cy="177800"/>
+          </a:xfrm>
+          <a:prstGeom prst="rect">
+            <a:avLst/>
+          </a:prstGeom>
+          <a:noFill/>
+          <a:ln/>
+        </p:spPr>
+        <p:txBody>
+          <a:bodyPr wrap="none" lIns="0" tIns="0" rIns="0" bIns="0" rtlCol="0" anchor="t"/>
+          <a:lstStyle/>
+          <a:p>
+            <a:pPr algn="ctr" indent="0" marL="0">
+              <a:buNone/>
+            </a:pPr>
+            <a:r>
+              <a:rPr lang="en-US" altLang="en-US" sz="1100" dirty="0">
+                <a:solidFill>
+                  <a:srgbClr val="F9F8F4"/>
+                </a:solidFill>
+                <a:latin typeface="Inter" pitchFamily="34" charset="0"/>
+                <a:ea typeface="Inter" pitchFamily="34" charset="-122"/>
+                <a:cs typeface="Inter" pitchFamily="34" charset="-120"/>
+              </a:rPr>
+              <a:t>MODELO COMUM + GOVERNANÇA</a:t>
+            </a:r>
+            <a:endParaRPr lang="en-US" sz="1100" dirty="0"/>
+          </a:p>
+        </p:txBody>
+      </p:sp>
+      <p:sp>
+        <p:nvSpPr>
+          <p:cNvPr id="20" name="visao-shape-19"/>
           <p:cNvSpPr/>
           <p:nvPr/>
         </p:nvSpPr>
@@ -2356,7 +2697,7 @@
       </p:sp>
       <p:sp>
         <p:nvSpPr>
-          <p:cNvPr id="18" name="visao-shape-17"/>
+          <p:cNvPr id="21" name="visao-shape-20"/>
           <p:cNvSpPr/>
           <p:nvPr/>
         </p:nvSpPr>
@@ -2378,7 +2719,7 @@
       </p:sp>
       <p:sp>
         <p:nvSpPr>
-          <p:cNvPr id="19" name="visao-shape-18"/>
+          <p:cNvPr id="22" name="visao-shape-21"/>
           <p:cNvSpPr/>
           <p:nvPr/>
         </p:nvSpPr>
@@ -2400,7 +2741,7 @@
       </p:sp>
       <p:sp>
         <p:nvSpPr>
-          <p:cNvPr id="20" name="visao-shape-19"/>
+          <p:cNvPr id="23" name="visao-shape-22"/>
           <p:cNvSpPr/>
           <p:nvPr/>
         </p:nvSpPr>
@@ -2422,7 +2763,7 @@
       </p:sp>
       <p:sp>
         <p:nvSpPr>
-          <p:cNvPr id="21" name="visao-shape-20"/>
+          <p:cNvPr id="24" name="visao-shape-23"/>
           <p:cNvSpPr/>
           <p:nvPr/>
         </p:nvSpPr>
@@ -2444,7 +2785,7 @@
       </p:sp>
       <p:sp>
         <p:nvSpPr>
-          <p:cNvPr id="22" name="visao-shape-21"/>
+          <p:cNvPr id="25" name="visao-shape-24"/>
           <p:cNvSpPr/>
           <p:nvPr/>
         </p:nvSpPr>
@@ -2469,7 +2810,7 @@
       </p:sp>
       <p:sp>
         <p:nvSpPr>
-          <p:cNvPr id="23" name="visao-text-22"/>
+          <p:cNvPr id="26" name="visao-text-25"/>
           <p:cNvSpPr/>
           <p:nvPr/>
         </p:nvSpPr>
@@ -2525,7 +2866,7 @@
       </p:sp>
       <p:sp>
         <p:nvSpPr>
-          <p:cNvPr id="24" name="visao-shape-23"/>
+          <p:cNvPr id="27" name="visao-shape-26"/>
           <p:cNvSpPr/>
           <p:nvPr/>
         </p:nvSpPr>
@@ -2550,7 +2891,7 @@
       </p:sp>
       <p:sp>
         <p:nvSpPr>
-          <p:cNvPr id="25" name="visao-text-24"/>
+          <p:cNvPr id="28" name="visao-text-27"/>
           <p:cNvSpPr/>
           <p:nvPr/>
         </p:nvSpPr>
@@ -2606,7 +2947,7 @@
       </p:sp>
       <p:sp>
         <p:nvSpPr>
-          <p:cNvPr id="26" name="visao-shape-25"/>
+          <p:cNvPr id="29" name="visao-shape-28"/>
           <p:cNvSpPr/>
           <p:nvPr/>
         </p:nvSpPr>
@@ -2631,7 +2972,7 @@
       </p:sp>
       <p:sp>
         <p:nvSpPr>
-          <p:cNvPr id="27" name="visao-text-26"/>
+          <p:cNvPr id="30" name="visao-text-29"/>
           <p:cNvSpPr/>
           <p:nvPr/>
         </p:nvSpPr>
@@ -2687,7 +3028,7 @@
       </p:sp>
       <p:sp>
         <p:nvSpPr>
-          <p:cNvPr id="28" name="visao-text-27"/>
+          <p:cNvPr id="31" name="visao-text-30"/>
           <p:cNvSpPr/>
           <p:nvPr/>
         </p:nvSpPr>
@@ -3751,7 +4092,88 @@
       </p:sp>
       <p:sp>
         <p:nvSpPr>
-          <p:cNvPr id="30" name="arquitetura-text-29"/>
+          <p:cNvPr id="30" name="arquitetura-shape-29"/>
+          <p:cNvSpPr/>
+          <p:nvPr/>
+        </p:nvSpPr>
+        <p:spPr>
+          <a:xfrm>
+            <a:off x="9474200" y="2413000"/>
+            <a:ext cx="3429000" cy="5816600"/>
+          </a:xfrm>
+          <a:prstGeom prst="rect">
+            <a:avLst/>
+          </a:prstGeom>
+          <a:ln w="25400">
+            <a:solidFill>
+              <a:srgbClr val="1C5D6C"/>
+            </a:solidFill>
+            <a:prstDash val="dash"/>
+          </a:ln>
+        </p:spPr>
+      </p:sp>
+      <p:sp>
+        <p:nvSpPr>
+          <p:cNvPr id="31" name="arquitetura-shape-30"/>
+          <p:cNvSpPr/>
+          <p:nvPr/>
+        </p:nvSpPr>
+        <p:spPr>
+          <a:xfrm>
+            <a:off x="9728200" y="2286000"/>
+            <a:ext cx="2032000" cy="304800"/>
+          </a:xfrm>
+          <a:prstGeom prst="rect">
+            <a:avLst/>
+          </a:prstGeom>
+          <a:solidFill>
+            <a:srgbClr val="F9F8F4"/>
+          </a:solidFill>
+          <a:ln/>
+        </p:spPr>
+      </p:sp>
+      <p:sp>
+        <p:nvSpPr>
+          <p:cNvPr id="32" name="arquitetura-text-31"/>
+          <p:cNvSpPr/>
+          <p:nvPr/>
+        </p:nvSpPr>
+        <p:spPr>
+          <a:xfrm>
+            <a:off x="9855200" y="2362200"/>
+            <a:ext cx="1778000" cy="152400"/>
+          </a:xfrm>
+          <a:prstGeom prst="rect">
+            <a:avLst/>
+          </a:prstGeom>
+          <a:noFill/>
+          <a:ln/>
+        </p:spPr>
+        <p:txBody>
+          <a:bodyPr wrap="none" lIns="0" tIns="0" rIns="0" bIns="0" rtlCol="0" anchor="t"/>
+          <a:lstStyle/>
+          <a:p>
+            <a:pPr algn="ctr" indent="0" marL="0">
+              <a:buNone/>
+            </a:pPr>
+            <a:r>
+              <a:rPr lang="en-US" altLang="en-US" sz="1100" dirty="0">
+                <a:solidFill>
+                  <a:srgbClr val="1C5D6C"/>
+                </a:solidFill>
+                <a:latin typeface="Inter" pitchFamily="34" charset="0"/>
+                <a:ea typeface="Inter" pitchFamily="34" charset="-122"/>
+                <a:cs typeface="Inter" pitchFamily="34" charset="-120"/>
+              </a:rPr>
+              <a:t>REDE PRIVADA</a:t>
+            </a:r>
+            <a:endParaRPr lang="en-US" sz="1100" dirty="0"/>
+          </a:p>
+        </p:txBody>
+      </p:sp>
+      <p:sp>
+        <p:nvSpPr>
+          <p:cNvPr id="33" name="arquitetura-text-32"/>
           <p:cNvSpPr/>
           <p:nvPr/>
         </p:nvSpPr>
@@ -4428,7 +4850,163 @@
       </p:sp>
       <p:sp>
         <p:nvSpPr>
-          <p:cNvPr id="21" name="fluxo_importacao-shape-20"/>
+          <p:cNvPr id="21" name="fluxo_importacao-text-20"/>
+          <p:cNvSpPr/>
+          <p:nvPr/>
+        </p:nvSpPr>
+        <p:spPr>
+          <a:xfrm>
+            <a:off x="635000" y="5283200"/>
+            <a:ext cx="2857500" cy="228600"/>
+          </a:xfrm>
+          <a:prstGeom prst="rect">
+            <a:avLst/>
+          </a:prstGeom>
+          <a:noFill/>
+          <a:ln/>
+        </p:spPr>
+        <p:txBody>
+          <a:bodyPr wrap="none" lIns="0" tIns="0" rIns="0" bIns="0" rtlCol="0" anchor="t"/>
+          <a:lstStyle/>
+          <a:p>
+            <a:pPr algn="ctr" indent="0" marL="0">
+              <a:buNone/>
+            </a:pPr>
+            <a:r>
+              <a:rPr lang="en-US" altLang="en-US" sz="1200" dirty="0">
+                <a:solidFill>
+                  <a:srgbClr val="1C5D6C"/>
+                </a:solidFill>
+                <a:latin typeface="Inter" pitchFamily="34" charset="0"/>
+                <a:ea typeface="Inter" pitchFamily="34" charset="-122"/>
+                <a:cs typeface="Inter" pitchFamily="34" charset="-120"/>
+              </a:rPr>
+              <a:t>STATUS: UPLOADED</a:t>
+            </a:r>
+            <a:endParaRPr lang="en-US" sz="1200" dirty="0"/>
+          </a:p>
+        </p:txBody>
+      </p:sp>
+      <p:sp>
+        <p:nvSpPr>
+          <p:cNvPr id="22" name="fluxo_importacao-text-21"/>
+          <p:cNvSpPr/>
+          <p:nvPr/>
+        </p:nvSpPr>
+        <p:spPr>
+          <a:xfrm>
+            <a:off x="4229100" y="5283200"/>
+            <a:ext cx="2857500" cy="228600"/>
+          </a:xfrm>
+          <a:prstGeom prst="rect">
+            <a:avLst/>
+          </a:prstGeom>
+          <a:noFill/>
+          <a:ln/>
+        </p:spPr>
+        <p:txBody>
+          <a:bodyPr wrap="none" lIns="0" tIns="0" rIns="0" bIns="0" rtlCol="0" anchor="t"/>
+          <a:lstStyle/>
+          <a:p>
+            <a:pPr algn="ctr" indent="0" marL="0">
+              <a:buNone/>
+            </a:pPr>
+            <a:r>
+              <a:rPr lang="en-US" altLang="en-US" sz="1200" dirty="0">
+                <a:solidFill>
+                  <a:srgbClr val="1C5D6C"/>
+                </a:solidFill>
+                <a:latin typeface="Inter" pitchFamily="34" charset="0"/>
+                <a:ea typeface="Inter" pitchFamily="34" charset="-122"/>
+                <a:cs typeface="Inter" pitchFamily="34" charset="-120"/>
+              </a:rPr>
+              <a:t>STATUS: MAPPED</a:t>
+            </a:r>
+            <a:endParaRPr lang="en-US" sz="1200" dirty="0"/>
+          </a:p>
+        </p:txBody>
+      </p:sp>
+      <p:sp>
+        <p:nvSpPr>
+          <p:cNvPr id="23" name="fluxo_importacao-text-22"/>
+          <p:cNvSpPr/>
+          <p:nvPr/>
+        </p:nvSpPr>
+        <p:spPr>
+          <a:xfrm>
+            <a:off x="7823200" y="5283200"/>
+            <a:ext cx="2857500" cy="228600"/>
+          </a:xfrm>
+          <a:prstGeom prst="rect">
+            <a:avLst/>
+          </a:prstGeom>
+          <a:noFill/>
+          <a:ln/>
+        </p:spPr>
+        <p:txBody>
+          <a:bodyPr wrap="none" lIns="0" tIns="0" rIns="0" bIns="0" rtlCol="0" anchor="t"/>
+          <a:lstStyle/>
+          <a:p>
+            <a:pPr algn="ctr" indent="0" marL="0">
+              <a:buNone/>
+            </a:pPr>
+            <a:r>
+              <a:rPr lang="en-US" altLang="en-US" sz="1200" dirty="0">
+                <a:solidFill>
+                  <a:srgbClr val="1C5D6C"/>
+                </a:solidFill>
+                <a:latin typeface="Inter" pitchFamily="34" charset="0"/>
+                <a:ea typeface="Inter" pitchFamily="34" charset="-122"/>
+                <a:cs typeface="Inter" pitchFamily="34" charset="-120"/>
+              </a:rPr>
+              <a:t>STATUS: VALIDATED</a:t>
+            </a:r>
+            <a:endParaRPr lang="en-US" sz="1200" dirty="0"/>
+          </a:p>
+        </p:txBody>
+      </p:sp>
+      <p:sp>
+        <p:nvSpPr>
+          <p:cNvPr id="24" name="fluxo_importacao-text-23"/>
+          <p:cNvSpPr/>
+          <p:nvPr/>
+        </p:nvSpPr>
+        <p:spPr>
+          <a:xfrm>
+            <a:off x="11417300" y="5283200"/>
+            <a:ext cx="4127500" cy="228600"/>
+          </a:xfrm>
+          <a:prstGeom prst="rect">
+            <a:avLst/>
+          </a:prstGeom>
+          <a:noFill/>
+          <a:ln/>
+        </p:spPr>
+        <p:txBody>
+          <a:bodyPr wrap="none" lIns="0" tIns="0" rIns="0" bIns="0" rtlCol="0" anchor="t"/>
+          <a:lstStyle/>
+          <a:p>
+            <a:pPr algn="ctr" indent="0" marL="0">
+              <a:buNone/>
+            </a:pPr>
+            <a:r>
+              <a:rPr lang="en-US" altLang="en-US" sz="1200" dirty="0">
+                <a:solidFill>
+                  <a:srgbClr val="143D2A"/>
+                </a:solidFill>
+                <a:latin typeface="Inter" pitchFamily="34" charset="0"/>
+                <a:ea typeface="Inter" pitchFamily="34" charset="-122"/>
+                <a:cs typeface="Inter" pitchFamily="34" charset="-120"/>
+              </a:rPr>
+              <a:t>STATUS: COMPLETED / PARTIAL</a:t>
+            </a:r>
+            <a:endParaRPr lang="en-US" sz="1200" dirty="0"/>
+          </a:p>
+        </p:txBody>
+      </p:sp>
+      <p:sp>
+        <p:nvSpPr>
+          <p:cNvPr id="25" name="fluxo_importacao-shape-24"/>
           <p:cNvSpPr/>
           <p:nvPr/>
         </p:nvSpPr>
@@ -4453,7 +5031,7 @@
       </p:sp>
       <p:pic>
         <p:nvPicPr>
-          <p:cNvPr id="22" name="fluxo_importacao-icon-21" descr="preencoded.png">    </p:cNvPr>
+          <p:cNvPr id="26" name="fluxo_importacao-icon-25" descr="preencoded.png">    </p:cNvPr>
           <p:cNvPicPr>
             <a:picLocks noChangeAspect="1"/>
           </p:cNvPicPr>
@@ -4477,7 +5055,7 @@
       </p:pic>
       <p:sp>
         <p:nvSpPr>
-          <p:cNvPr id="23" name="fluxo_importacao-text-22"/>
+          <p:cNvPr id="27" name="fluxo_importacao-text-26"/>
           <p:cNvSpPr/>
           <p:nvPr/>
         </p:nvSpPr>
@@ -4527,7 +5105,7 @@
       </p:sp>
       <p:sp>
         <p:nvSpPr>
-          <p:cNvPr id="24" name="fluxo_importacao-text-23"/>
+          <p:cNvPr id="28" name="fluxo_importacao-text-27"/>
           <p:cNvSpPr/>
           <p:nvPr/>
         </p:nvSpPr>
@@ -4733,9 +5311,127 @@
           </a:p>
         </p:txBody>
       </p:sp>
+      <p:sp>
+        <p:nvSpPr>
+          <p:cNvPr id="6" name="template-shape-5"/>
+          <p:cNvSpPr/>
+          <p:nvPr/>
+        </p:nvSpPr>
+        <p:spPr>
+          <a:xfrm>
+            <a:off x="11709400" y="1676400"/>
+            <a:ext cx="1752600" cy="355600"/>
+          </a:xfrm>
+          <a:prstGeom prst="rect">
+            <a:avLst/>
+          </a:prstGeom>
+          <a:solidFill>
+            <a:srgbClr val="143D2A"/>
+          </a:solidFill>
+          <a:ln/>
+        </p:spPr>
+      </p:sp>
+      <p:sp>
+        <p:nvSpPr>
+          <p:cNvPr id="7" name="template-text-6"/>
+          <p:cNvSpPr/>
+          <p:nvPr/>
+        </p:nvSpPr>
+        <p:spPr>
+          <a:xfrm>
+            <a:off x="11836400" y="1778000"/>
+            <a:ext cx="1498600" cy="152400"/>
+          </a:xfrm>
+          <a:prstGeom prst="rect">
+            <a:avLst/>
+          </a:prstGeom>
+          <a:noFill/>
+          <a:ln/>
+        </p:spPr>
+        <p:txBody>
+          <a:bodyPr wrap="none" lIns="0" tIns="0" rIns="0" bIns="0" rtlCol="0" anchor="t"/>
+          <a:lstStyle/>
+          <a:p>
+            <a:pPr algn="ctr" indent="0" marL="0">
+              <a:buNone/>
+            </a:pPr>
+            <a:r>
+              <a:rPr lang="en-US" altLang="en-US" sz="1100" dirty="0">
+                <a:solidFill>
+                  <a:srgbClr val="F9F8F4"/>
+                </a:solidFill>
+                <a:latin typeface="Inter" pitchFamily="34" charset="0"/>
+                <a:ea typeface="Inter" pitchFamily="34" charset="-122"/>
+                <a:cs typeface="Inter" pitchFamily="34" charset="-120"/>
+              </a:rPr>
+              <a:t>4 IMPORTÁVEIS</a:t>
+            </a:r>
+            <a:endParaRPr lang="en-US" sz="1100" dirty="0"/>
+          </a:p>
+        </p:txBody>
+      </p:sp>
+      <p:sp>
+        <p:nvSpPr>
+          <p:cNvPr id="8" name="template-shape-7"/>
+          <p:cNvSpPr/>
+          <p:nvPr/>
+        </p:nvSpPr>
+        <p:spPr>
+          <a:xfrm>
+            <a:off x="13589000" y="1676400"/>
+            <a:ext cx="1778000" cy="355600"/>
+          </a:xfrm>
+          <a:prstGeom prst="rect">
+            <a:avLst/>
+          </a:prstGeom>
+          <a:solidFill>
+            <a:srgbClr val="1C5D6C"/>
+          </a:solidFill>
+          <a:ln/>
+        </p:spPr>
+      </p:sp>
+      <p:sp>
+        <p:nvSpPr>
+          <p:cNvPr id="9" name="template-text-8"/>
+          <p:cNvSpPr/>
+          <p:nvPr/>
+        </p:nvSpPr>
+        <p:spPr>
+          <a:xfrm>
+            <a:off x="13716000" y="1778000"/>
+            <a:ext cx="1524000" cy="152400"/>
+          </a:xfrm>
+          <a:prstGeom prst="rect">
+            <a:avLst/>
+          </a:prstGeom>
+          <a:noFill/>
+          <a:ln/>
+        </p:spPr>
+        <p:txBody>
+          <a:bodyPr wrap="none" lIns="0" tIns="0" rIns="0" bIns="0" rtlCol="0" anchor="t"/>
+          <a:lstStyle/>
+          <a:p>
+            <a:pPr algn="ctr" indent="0" marL="0">
+              <a:buNone/>
+            </a:pPr>
+            <a:r>
+              <a:rPr lang="en-US" altLang="en-US" sz="1100" dirty="0">
+                <a:solidFill>
+                  <a:srgbClr val="F9F8F4"/>
+                </a:solidFill>
+                <a:latin typeface="Inter" pitchFamily="34" charset="0"/>
+                <a:ea typeface="Inter" pitchFamily="34" charset="-122"/>
+                <a:cs typeface="Inter" pitchFamily="34" charset="-120"/>
+              </a:rPr>
+              <a:t>3 PREPARADAS</a:t>
+            </a:r>
+            <a:endParaRPr lang="en-US" sz="1100" dirty="0"/>
+          </a:p>
+        </p:txBody>
+      </p:sp>
       <p:graphicFrame>
         <p:nvGraphicFramePr>
-          <p:cNvPr id="6" name="template-table-5"/>
+          <p:cNvPr id="10" name="template-table-9"/>
           <p:cNvGraphicFramePr>
             <a:graphicFrameLocks noGrp="1"/>
           </p:cNvGraphicFramePr>
@@ -5631,7 +6327,7 @@
                       <a:tailEnd type="none" w="med" len="med"/>
                     </a:lnB>
                     <a:solidFill>
-                      <a:srgbClr val="F0EFE9"/>
+                      <a:srgbClr val="E2EEE6"/>
                     </a:solidFill>
                   </a:tcPr>
                 </a:tc>
@@ -5699,7 +6395,7 @@
                       <a:tailEnd type="none" w="med" len="med"/>
                     </a:lnB>
                     <a:solidFill>
-                      <a:srgbClr val="F0EFE9"/>
+                      <a:srgbClr val="E2EEE6"/>
                     </a:solidFill>
                   </a:tcPr>
                 </a:tc>
@@ -5712,9 +6408,9 @@
                         <a:buNone/>
                       </a:pPr>
                       <a:r>
-                        <a:rPr lang="en-US" altLang="en-US" sz="1500" dirty="0">
+                        <a:rPr lang="en-US" altLang="en-US" sz="1500" b="1" dirty="0">
                           <a:solidFill>
-                            <a:srgbClr val="101C17"/>
+                            <a:srgbClr val="143D2A"/>
                           </a:solidFill>
                           <a:latin typeface="Inter" pitchFamily="34" charset="0"/>
                           <a:ea typeface="Inter" pitchFamily="34" charset="-122"/>
@@ -5767,7 +6463,7 @@
                       <a:tailEnd type="none" w="med" len="med"/>
                     </a:lnB>
                     <a:solidFill>
-                      <a:srgbClr val="F0EFE9"/>
+                      <a:srgbClr val="E2EEE6"/>
                     </a:solidFill>
                   </a:tcPr>
                 </a:tc>
@@ -5836,6 +6532,9 @@
                       <a:headEnd type="none" w="med" len="med"/>
                       <a:tailEnd type="none" w="med" len="med"/>
                     </a:lnB>
+                    <a:solidFill>
+                      <a:srgbClr val="E2EEE6"/>
+                    </a:solidFill>
                   </a:tcPr>
                 </a:tc>
                 <a:tc>
@@ -5901,6 +6600,9 @@
                       <a:headEnd type="none" w="med" len="med"/>
                       <a:tailEnd type="none" w="med" len="med"/>
                     </a:lnB>
+                    <a:solidFill>
+                      <a:srgbClr val="E2EEE6"/>
+                    </a:solidFill>
                   </a:tcPr>
                 </a:tc>
                 <a:tc>
@@ -5912,9 +6614,9 @@
                         <a:buNone/>
                       </a:pPr>
                       <a:r>
-                        <a:rPr lang="en-US" altLang="en-US" sz="1500" dirty="0">
+                        <a:rPr lang="en-US" altLang="en-US" sz="1500" b="1" dirty="0">
                           <a:solidFill>
-                            <a:srgbClr val="101C17"/>
+                            <a:srgbClr val="143D2A"/>
                           </a:solidFill>
                           <a:latin typeface="Inter" pitchFamily="34" charset="0"/>
                           <a:ea typeface="Inter" pitchFamily="34" charset="-122"/>
@@ -5966,6 +6668,9 @@
                       <a:headEnd type="none" w="med" len="med"/>
                       <a:tailEnd type="none" w="med" len="med"/>
                     </a:lnB>
+                    <a:solidFill>
+                      <a:srgbClr val="E2EEE6"/>
+                    </a:solidFill>
                   </a:tcPr>
                 </a:tc>
               </a:tr>
@@ -6034,7 +6739,7 @@
                       <a:tailEnd type="none" w="med" len="med"/>
                     </a:lnB>
                     <a:solidFill>
-                      <a:srgbClr val="F0EFE9"/>
+                      <a:srgbClr val="E2EEE6"/>
                     </a:solidFill>
                   </a:tcPr>
                 </a:tc>
@@ -6102,7 +6807,7 @@
                       <a:tailEnd type="none" w="med" len="med"/>
                     </a:lnB>
                     <a:solidFill>
-                      <a:srgbClr val="F0EFE9"/>
+                      <a:srgbClr val="E2EEE6"/>
                     </a:solidFill>
                   </a:tcPr>
                 </a:tc>
@@ -6115,9 +6820,9 @@
                         <a:buNone/>
                       </a:pPr>
                       <a:r>
-                        <a:rPr lang="en-US" altLang="en-US" sz="1500" dirty="0">
+                        <a:rPr lang="en-US" altLang="en-US" sz="1500" b="1" dirty="0">
                           <a:solidFill>
-                            <a:srgbClr val="101C17"/>
+                            <a:srgbClr val="143D2A"/>
                           </a:solidFill>
                           <a:latin typeface="Inter" pitchFamily="34" charset="0"/>
                           <a:ea typeface="Inter" pitchFamily="34" charset="-122"/>
@@ -6170,7 +6875,7 @@
                       <a:tailEnd type="none" w="med" len="med"/>
                     </a:lnB>
                     <a:solidFill>
-                      <a:srgbClr val="F0EFE9"/>
+                      <a:srgbClr val="E2EEE6"/>
                     </a:solidFill>
                   </a:tcPr>
                 </a:tc>
@@ -6239,6 +6944,9 @@
                       <a:headEnd type="none" w="med" len="med"/>
                       <a:tailEnd type="none" w="med" len="med"/>
                     </a:lnB>
+                    <a:solidFill>
+                      <a:srgbClr val="E2EEE6"/>
+                    </a:solidFill>
                   </a:tcPr>
                 </a:tc>
                 <a:tc>
@@ -6304,6 +7012,9 @@
                       <a:headEnd type="none" w="med" len="med"/>
                       <a:tailEnd type="none" w="med" len="med"/>
                     </a:lnB>
+                    <a:solidFill>
+                      <a:srgbClr val="E2EEE6"/>
+                    </a:solidFill>
                   </a:tcPr>
                 </a:tc>
                 <a:tc>
@@ -6315,9 +7026,9 @@
                         <a:buNone/>
                       </a:pPr>
                       <a:r>
-                        <a:rPr lang="en-US" altLang="en-US" sz="1500" dirty="0">
+                        <a:rPr lang="en-US" altLang="en-US" sz="1500" b="1" dirty="0">
                           <a:solidFill>
-                            <a:srgbClr val="101C17"/>
+                            <a:srgbClr val="143D2A"/>
                           </a:solidFill>
                           <a:latin typeface="Inter" pitchFamily="34" charset="0"/>
                           <a:ea typeface="Inter" pitchFamily="34" charset="-122"/>
@@ -6369,6 +7080,9 @@
                       <a:headEnd type="none" w="med" len="med"/>
                       <a:tailEnd type="none" w="med" len="med"/>
                     </a:lnB>
+                    <a:solidFill>
+                      <a:srgbClr val="E2EEE6"/>
+                    </a:solidFill>
                   </a:tcPr>
                 </a:tc>
               </a:tr>
@@ -6437,7 +7151,7 @@
                       <a:tailEnd type="none" w="med" len="med"/>
                     </a:lnB>
                     <a:solidFill>
-                      <a:srgbClr val="F0EFE9"/>
+                      <a:srgbClr val="E2EEE6"/>
                     </a:solidFill>
                   </a:tcPr>
                 </a:tc>
@@ -6505,7 +7219,7 @@
                       <a:tailEnd type="none" w="med" len="med"/>
                     </a:lnB>
                     <a:solidFill>
-                      <a:srgbClr val="F0EFE9"/>
+                      <a:srgbClr val="E2EEE6"/>
                     </a:solidFill>
                   </a:tcPr>
                 </a:tc>
@@ -6518,9 +7232,9 @@
                         <a:buNone/>
                       </a:pPr>
                       <a:r>
-                        <a:rPr lang="en-US" altLang="en-US" sz="1500" dirty="0">
+                        <a:rPr lang="en-US" altLang="en-US" sz="1500" b="1" dirty="0">
                           <a:solidFill>
-                            <a:srgbClr val="101C17"/>
+                            <a:srgbClr val="143D2A"/>
                           </a:solidFill>
                           <a:latin typeface="Inter" pitchFamily="34" charset="0"/>
                           <a:ea typeface="Inter" pitchFamily="34" charset="-122"/>
@@ -6573,7 +7287,7 @@
                       <a:tailEnd type="none" w="med" len="med"/>
                     </a:lnB>
                     <a:solidFill>
-                      <a:srgbClr val="F0EFE9"/>
+                      <a:srgbClr val="E2EEE6"/>
                     </a:solidFill>
                   </a:tcPr>
                 </a:tc>
@@ -6987,7 +7701,7 @@
       </p:graphicFrame>
       <p:sp>
         <p:nvSpPr>
-          <p:cNvPr id="7" name="template-text-6"/>
+          <p:cNvPr id="11" name="template-text-10"/>
           <p:cNvSpPr/>
           <p:nvPr/>
         </p:nvSpPr>
@@ -7162,6 +7876,65 @@
         </p:nvSpPr>
         <p:spPr>
           <a:xfrm>
+            <a:off x="12890500" y="990600"/>
+            <a:ext cx="2413000" cy="406400"/>
+          </a:xfrm>
+          <a:prstGeom prst="rect">
+            <a:avLst/>
+          </a:prstGeom>
+          <a:solidFill>
+            <a:srgbClr val="B84A39"/>
+          </a:solidFill>
+          <a:ln/>
+        </p:spPr>
+      </p:sp>
+      <p:sp>
+        <p:nvSpPr>
+          <p:cNvPr id="6" name="validacoes-text-5"/>
+          <p:cNvSpPr/>
+          <p:nvPr/>
+        </p:nvSpPr>
+        <p:spPr>
+          <a:xfrm>
+            <a:off x="13017500" y="1104900"/>
+            <a:ext cx="2159000" cy="177800"/>
+          </a:xfrm>
+          <a:prstGeom prst="rect">
+            <a:avLst/>
+          </a:prstGeom>
+          <a:noFill/>
+          <a:ln/>
+        </p:spPr>
+        <p:txBody>
+          <a:bodyPr wrap="none" lIns="0" tIns="0" rIns="0" bIns="0" rtlCol="0" anchor="t"/>
+          <a:lstStyle/>
+          <a:p>
+            <a:pPr algn="ctr" indent="0" marL="0">
+              <a:buNone/>
+            </a:pPr>
+            <a:r>
+              <a:rPr lang="en-US" altLang="en-US" sz="1200" dirty="0">
+                <a:solidFill>
+                  <a:srgbClr val="F9F8F4"/>
+                </a:solidFill>
+                <a:latin typeface="Inter" pitchFamily="34" charset="0"/>
+                <a:ea typeface="Inter" pitchFamily="34" charset="-122"/>
+                <a:cs typeface="Inter" pitchFamily="34" charset="-120"/>
+              </a:rPr>
+              <a:t>BLOQUEIA ERRO SILENCIOSO</a:t>
+            </a:r>
+            <a:endParaRPr lang="en-US" sz="1200" dirty="0"/>
+          </a:p>
+        </p:txBody>
+      </p:sp>
+      <p:sp>
+        <p:nvSpPr>
+          <p:cNvPr id="7" name="validacoes-shape-6"/>
+          <p:cNvSpPr/>
+          <p:nvPr/>
+        </p:nvSpPr>
+        <p:spPr>
+          <a:xfrm>
             <a:off x="939800" y="2311400"/>
             <a:ext cx="14351000" cy="787400"/>
           </a:xfrm>
@@ -7176,7 +7949,7 @@
       </p:sp>
       <p:sp>
         <p:nvSpPr>
-          <p:cNvPr id="6" name="validacoes-text-5"/>
+          <p:cNvPr id="8" name="validacoes-text-7"/>
           <p:cNvSpPr/>
           <p:nvPr/>
         </p:nvSpPr>
@@ -7226,7 +7999,7 @@
       </p:sp>
       <p:sp>
         <p:nvSpPr>
-          <p:cNvPr id="7" name="validacoes-shape-6"/>
+          <p:cNvPr id="9" name="validacoes-shape-8"/>
           <p:cNvSpPr/>
           <p:nvPr/>
         </p:nvSpPr>
@@ -7248,7 +8021,7 @@
       </p:sp>
       <p:sp>
         <p:nvSpPr>
-          <p:cNvPr id="8" name="validacoes-text-7"/>
+          <p:cNvPr id="10" name="validacoes-text-9"/>
           <p:cNvSpPr/>
           <p:nvPr/>
         </p:nvSpPr>
@@ -7298,7 +8071,7 @@
       </p:sp>
       <p:sp>
         <p:nvSpPr>
-          <p:cNvPr id="9" name="validacoes-shape-8"/>
+          <p:cNvPr id="11" name="validacoes-shape-10"/>
           <p:cNvSpPr/>
           <p:nvPr/>
         </p:nvSpPr>
@@ -7318,7 +8091,7 @@
       </p:sp>
       <p:sp>
         <p:nvSpPr>
-          <p:cNvPr id="10" name="validacoes-text-9"/>
+          <p:cNvPr id="12" name="validacoes-text-11"/>
           <p:cNvSpPr/>
           <p:nvPr/>
         </p:nvSpPr>
@@ -7368,7 +8141,7 @@
       </p:sp>
       <p:sp>
         <p:nvSpPr>
-          <p:cNvPr id="11" name="validacoes-shape-10"/>
+          <p:cNvPr id="13" name="validacoes-shape-12"/>
           <p:cNvSpPr/>
           <p:nvPr/>
         </p:nvSpPr>
@@ -7390,7 +8163,7 @@
       </p:sp>
       <p:sp>
         <p:nvSpPr>
-          <p:cNvPr id="12" name="validacoes-text-11"/>
+          <p:cNvPr id="14" name="validacoes-text-13"/>
           <p:cNvSpPr/>
           <p:nvPr/>
         </p:nvSpPr>
@@ -7440,7 +8213,7 @@
       </p:sp>
       <p:sp>
         <p:nvSpPr>
-          <p:cNvPr id="13" name="validacoes-shape-12"/>
+          <p:cNvPr id="15" name="validacoes-shape-14"/>
           <p:cNvSpPr/>
           <p:nvPr/>
         </p:nvSpPr>
@@ -7462,7 +8235,7 @@
       </p:sp>
       <p:sp>
         <p:nvSpPr>
-          <p:cNvPr id="14" name="validacoes-text-13"/>
+          <p:cNvPr id="16" name="validacoes-text-15"/>
           <p:cNvSpPr/>
           <p:nvPr/>
         </p:nvSpPr>
@@ -7512,7 +8285,7 @@
       </p:sp>
       <p:sp>
         <p:nvSpPr>
-          <p:cNvPr id="15" name="validacoes-shape-14"/>
+          <p:cNvPr id="17" name="validacoes-shape-16"/>
           <p:cNvSpPr/>
           <p:nvPr/>
         </p:nvSpPr>
@@ -7532,7 +8305,7 @@
       </p:sp>
       <p:sp>
         <p:nvSpPr>
-          <p:cNvPr id="16" name="validacoes-text-15"/>
+          <p:cNvPr id="18" name="validacoes-text-17"/>
           <p:cNvSpPr/>
           <p:nvPr/>
         </p:nvSpPr>
@@ -7582,7 +8355,46 @@
       </p:sp>
       <p:sp>
         <p:nvSpPr>
-          <p:cNvPr id="17" name="validacoes-text-16"/>
+          <p:cNvPr id="19" name="validacoes-text-18"/>
+          <p:cNvSpPr/>
+          <p:nvPr/>
+        </p:nvSpPr>
+        <p:spPr>
+          <a:xfrm>
+            <a:off x="13081000" y="7404100"/>
+            <a:ext cx="2159000" cy="203200"/>
+          </a:xfrm>
+          <a:prstGeom prst="rect">
+            <a:avLst/>
+          </a:prstGeom>
+          <a:noFill/>
+          <a:ln/>
+        </p:spPr>
+        <p:txBody>
+          <a:bodyPr wrap="none" lIns="0" tIns="0" rIns="0" bIns="0" rtlCol="0" anchor="t"/>
+          <a:lstStyle/>
+          <a:p>
+            <a:pPr algn="ctr" indent="0" marL="0">
+              <a:buNone/>
+            </a:pPr>
+            <a:r>
+              <a:rPr lang="en-US" altLang="en-US" sz="1100" dirty="0">
+                <a:solidFill>
+                  <a:srgbClr val="B84A39"/>
+                </a:solidFill>
+                <a:latin typeface="Inter" pitchFamily="34" charset="0"/>
+                <a:ea typeface="Inter" pitchFamily="34" charset="-122"/>
+                <a:cs typeface="Inter" pitchFamily="34" charset="-120"/>
+              </a:rPr>
+              <a:t>PROTEGE O DOMÍNIO</a:t>
+            </a:r>
+            <a:endParaRPr lang="en-US" sz="1100" dirty="0"/>
+          </a:p>
+        </p:txBody>
+      </p:sp>
+      <p:sp>
+        <p:nvSpPr>
+          <p:cNvPr id="20" name="validacoes-text-19"/>
           <p:cNvSpPr/>
           <p:nvPr/>
         </p:nvSpPr>
@@ -9434,7 +10246,7 @@
                       <a:r>
                         <a:rPr lang="en-US" altLang="en-US" sz="1600" b="1" dirty="0">
                           <a:solidFill>
-                            <a:srgbClr val="101C17"/>
+                            <a:srgbClr val="143D2A"/>
                           </a:solidFill>
                           <a:latin typeface="Inter" pitchFamily="34" charset="0"/>
                           <a:ea typeface="Inter" pitchFamily="34" charset="-122"/>
@@ -9487,7 +10299,7 @@
                       <a:tailEnd type="none" w="med" len="med"/>
                     </a:lnB>
                     <a:solidFill>
-                      <a:srgbClr val="F0EFE9"/>
+                      <a:srgbClr val="E2EEE6"/>
                     </a:solidFill>
                   </a:tcPr>
                 </a:tc>
@@ -9555,7 +10367,7 @@
                       <a:tailEnd type="none" w="med" len="med"/>
                     </a:lnB>
                     <a:solidFill>
-                      <a:srgbClr val="F0EFE9"/>
+                      <a:srgbClr val="E2EEE6"/>
                     </a:solidFill>
                   </a:tcPr>
                 </a:tc>
@@ -9623,7 +10435,7 @@
                       <a:tailEnd type="none" w="med" len="med"/>
                     </a:lnB>
                     <a:solidFill>
-                      <a:srgbClr val="F0EFE9"/>
+                      <a:srgbClr val="E2EEE6"/>
                     </a:solidFill>
                   </a:tcPr>
                 </a:tc>
@@ -9691,7 +10503,213 @@
                       <a:tailEnd type="none" w="med" len="med"/>
                     </a:lnB>
                     <a:solidFill>
-                      <a:srgbClr val="F0EFE9"/>
+                      <a:srgbClr val="E2EEE6"/>
+                    </a:solidFill>
+                  </a:tcPr>
+                </a:tc>
+                <a:tc>
+                  <a:txBody>
+                    <a:bodyPr/>
+                    <a:lstStyle/>
+                    <a:p>
+                      <a:pPr algn="ctr" indent="0" marL="0">
+                        <a:buNone/>
+                      </a:pPr>
+                      <a:r>
+                        <a:rPr lang="en-US" altLang="en-US" sz="1600" b="1" dirty="0">
+                          <a:solidFill>
+                            <a:srgbClr val="143D2A"/>
+                          </a:solidFill>
+                          <a:latin typeface="Inter" pitchFamily="34" charset="0"/>
+                          <a:ea typeface="Inter" pitchFamily="34" charset="-122"/>
+                          <a:cs typeface="Inter" pitchFamily="34" charset="-120"/>
+                        </a:rPr>
+                        <a:t>Sim</a:t>
+                      </a:r>
+                      <a:endParaRPr lang="en-US" sz="1600" dirty="0">
+                        <a:latin typeface="Inter" charset="0"/>
+                        <a:ea typeface="Inter" charset="0"/>
+                        <a:cs typeface="Inter" charset="0"/>
+                      </a:endParaRPr>
+                    </a:p>
+                  </a:txBody>
+                  <a:tcPr marL="152400" marR="152400" marT="127000" marB="127000" anchor="ctr">
+                    <a:lnL w="12700" cap="flat" cmpd="sng" algn="ctr">
+                      <a:solidFill>
+                        <a:srgbClr val="D4D1C6"/>
+                      </a:solidFill>
+                      <a:prstDash val="solid"/>
+                      <a:round/>
+                      <a:headEnd type="none" w="med" len="med"/>
+                      <a:tailEnd type="none" w="med" len="med"/>
+                    </a:lnL>
+                    <a:lnR w="12700" cap="flat" cmpd="sng" algn="ctr">
+                      <a:solidFill>
+                        <a:srgbClr val="D4D1C6"/>
+                      </a:solidFill>
+                      <a:prstDash val="solid"/>
+                      <a:round/>
+                      <a:headEnd type="none" w="med" len="med"/>
+                      <a:tailEnd type="none" w="med" len="med"/>
+                    </a:lnR>
+                    <a:lnT w="12700" cap="flat" cmpd="sng" algn="ctr">
+                      <a:solidFill>
+                        <a:srgbClr val="D4D1C6"/>
+                      </a:solidFill>
+                      <a:prstDash val="solid"/>
+                      <a:round/>
+                      <a:headEnd type="none" w="med" len="med"/>
+                      <a:tailEnd type="none" w="med" len="med"/>
+                    </a:lnT>
+                    <a:lnB w="12700" cap="flat" cmpd="sng" algn="ctr">
+                      <a:solidFill>
+                        <a:srgbClr val="D4D1C6"/>
+                      </a:solidFill>
+                      <a:prstDash val="solid"/>
+                      <a:round/>
+                      <a:headEnd type="none" w="med" len="med"/>
+                      <a:tailEnd type="none" w="med" len="med"/>
+                    </a:lnB>
+                    <a:solidFill>
+                      <a:srgbClr val="E2EEE6"/>
+                    </a:solidFill>
+                  </a:tcPr>
+                </a:tc>
+                <a:tc>
+                  <a:txBody>
+                    <a:bodyPr/>
+                    <a:lstStyle/>
+                    <a:p>
+                      <a:pPr algn="ctr" indent="0" marL="0">
+                        <a:buNone/>
+                      </a:pPr>
+                      <a:r>
+                        <a:rPr lang="en-US" altLang="en-US" sz="1600" b="1" dirty="0">
+                          <a:solidFill>
+                            <a:srgbClr val="143D2A"/>
+                          </a:solidFill>
+                          <a:latin typeface="Inter" pitchFamily="34" charset="0"/>
+                          <a:ea typeface="Inter" pitchFamily="34" charset="-122"/>
+                          <a:cs typeface="Inter" pitchFamily="34" charset="-120"/>
+                        </a:rPr>
+                        <a:t>Sim</a:t>
+                      </a:r>
+                      <a:endParaRPr lang="en-US" sz="1600" dirty="0">
+                        <a:latin typeface="Inter" charset="0"/>
+                        <a:ea typeface="Inter" charset="0"/>
+                        <a:cs typeface="Inter" charset="0"/>
+                      </a:endParaRPr>
+                    </a:p>
+                  </a:txBody>
+                  <a:tcPr marL="152400" marR="152400" marT="127000" marB="127000" anchor="ctr">
+                    <a:lnL w="12700" cap="flat" cmpd="sng" algn="ctr">
+                      <a:solidFill>
+                        <a:srgbClr val="D4D1C6"/>
+                      </a:solidFill>
+                      <a:prstDash val="solid"/>
+                      <a:round/>
+                      <a:headEnd type="none" w="med" len="med"/>
+                      <a:tailEnd type="none" w="med" len="med"/>
+                    </a:lnL>
+                    <a:lnR w="12700" cap="flat" cmpd="sng" algn="ctr">
+                      <a:solidFill>
+                        <a:srgbClr val="D4D1C6"/>
+                      </a:solidFill>
+                      <a:prstDash val="solid"/>
+                      <a:round/>
+                      <a:headEnd type="none" w="med" len="med"/>
+                      <a:tailEnd type="none" w="med" len="med"/>
+                    </a:lnR>
+                    <a:lnT w="12700" cap="flat" cmpd="sng" algn="ctr">
+                      <a:solidFill>
+                        <a:srgbClr val="D4D1C6"/>
+                      </a:solidFill>
+                      <a:prstDash val="solid"/>
+                      <a:round/>
+                      <a:headEnd type="none" w="med" len="med"/>
+                      <a:tailEnd type="none" w="med" len="med"/>
+                    </a:lnT>
+                    <a:lnB w="12700" cap="flat" cmpd="sng" algn="ctr">
+                      <a:solidFill>
+                        <a:srgbClr val="D4D1C6"/>
+                      </a:solidFill>
+                      <a:prstDash val="solid"/>
+                      <a:round/>
+                      <a:headEnd type="none" w="med" len="med"/>
+                      <a:tailEnd type="none" w="med" len="med"/>
+                    </a:lnB>
+                    <a:solidFill>
+                      <a:srgbClr val="E2EEE6"/>
+                    </a:solidFill>
+                  </a:tcPr>
+                </a:tc>
+              </a:tr>
+              <a:tr h="685800">
+                <a:tc>
+                  <a:txBody>
+                    <a:bodyPr/>
+                    <a:lstStyle/>
+                    <a:p>
+                      <a:pPr algn="l" indent="0" marL="0">
+                        <a:buNone/>
+                      </a:pPr>
+                      <a:r>
+                        <a:rPr lang="en-US" altLang="en-US" sz="1600" b="1" dirty="0">
+                          <a:solidFill>
+                            <a:srgbClr val="143D2A"/>
+                          </a:solidFill>
+                          <a:latin typeface="Inter" pitchFamily="34" charset="0"/>
+                          <a:ea typeface="Inter" pitchFamily="34" charset="-122"/>
+                          <a:cs typeface="Inter" pitchFamily="34" charset="-120"/>
+                        </a:rPr>
+                        <a:t>owner</a:t>
+                      </a:r>
+                      <a:endParaRPr lang="en-US" sz="1600" dirty="0">
+                        <a:latin typeface="Inter" charset="0"/>
+                        <a:ea typeface="Inter" charset="0"/>
+                        <a:cs typeface="Inter" charset="0"/>
+                      </a:endParaRPr>
+                    </a:p>
+                  </a:txBody>
+                  <a:tcPr marL="152400" marR="152400" marT="127000" marB="127000" anchor="ctr">
+                    <a:lnL w="12700" cap="flat" cmpd="sng" algn="ctr">
+                      <a:solidFill>
+                        <a:srgbClr val="D4D1C6"/>
+                      </a:solidFill>
+                      <a:prstDash val="solid"/>
+                      <a:round/>
+                      <a:headEnd type="none" w="med" len="med"/>
+                      <a:tailEnd type="none" w="med" len="med"/>
+                    </a:lnL>
+                    <a:lnR w="12700" cap="flat" cmpd="sng" algn="ctr">
+                      <a:solidFill>
+                        <a:srgbClr val="D4D1C6"/>
+                      </a:solidFill>
+                      <a:prstDash val="solid"/>
+                      <a:round/>
+                      <a:headEnd type="none" w="med" len="med"/>
+                      <a:tailEnd type="none" w="med" len="med"/>
+                    </a:lnR>
+                    <a:lnT w="12700" cap="flat" cmpd="sng" algn="ctr">
+                      <a:solidFill>
+                        <a:srgbClr val="D4D1C6"/>
+                      </a:solidFill>
+                      <a:prstDash val="solid"/>
+                      <a:round/>
+                      <a:headEnd type="none" w="med" len="med"/>
+                      <a:tailEnd type="none" w="med" len="med"/>
+                    </a:lnT>
+                    <a:lnB w="12700" cap="flat" cmpd="sng" algn="ctr">
+                      <a:solidFill>
+                        <a:srgbClr val="D4D1C6"/>
+                      </a:solidFill>
+                      <a:prstDash val="solid"/>
+                      <a:round/>
+                      <a:headEnd type="none" w="med" len="med"/>
+                      <a:tailEnd type="none" w="med" len="med"/>
+                    </a:lnB>
+                    <a:solidFill>
+                      <a:srgbClr val="D1E4D6"/>
                     </a:solidFill>
                   </a:tcPr>
                 </a:tc>
@@ -9759,7 +10777,7 @@
                       <a:tailEnd type="none" w="med" len="med"/>
                     </a:lnB>
                     <a:solidFill>
-                      <a:srgbClr val="F0EFE9"/>
+                      <a:srgbClr val="D1E4D6"/>
                     </a:solidFill>
                   </a:tcPr>
                 </a:tc>
@@ -9827,75 +10845,8 @@
                       <a:tailEnd type="none" w="med" len="med"/>
                     </a:lnB>
                     <a:solidFill>
-                      <a:srgbClr val="F0EFE9"/>
+                      <a:srgbClr val="D1E4D6"/>
                     </a:solidFill>
-                  </a:tcPr>
-                </a:tc>
-              </a:tr>
-              <a:tr h="685800">
-                <a:tc>
-                  <a:txBody>
-                    <a:bodyPr/>
-                    <a:lstStyle/>
-                    <a:p>
-                      <a:pPr algn="l" indent="0" marL="0">
-                        <a:buNone/>
-                      </a:pPr>
-                      <a:r>
-                        <a:rPr lang="en-US" altLang="en-US" sz="1600" b="1" dirty="0">
-                          <a:solidFill>
-                            <a:srgbClr val="101C17"/>
-                          </a:solidFill>
-                          <a:latin typeface="Inter" pitchFamily="34" charset="0"/>
-                          <a:ea typeface="Inter" pitchFamily="34" charset="-122"/>
-                          <a:cs typeface="Inter" pitchFamily="34" charset="-120"/>
-                        </a:rPr>
-                        <a:t>owner</a:t>
-                      </a:r>
-                      <a:endParaRPr lang="en-US" sz="1600" dirty="0">
-                        <a:latin typeface="Inter" charset="0"/>
-                        <a:ea typeface="Inter" charset="0"/>
-                        <a:cs typeface="Inter" charset="0"/>
-                      </a:endParaRPr>
-                    </a:p>
-                  </a:txBody>
-                  <a:tcPr marL="152400" marR="152400" marT="127000" marB="127000" anchor="ctr">
-                    <a:lnL w="12700" cap="flat" cmpd="sng" algn="ctr">
-                      <a:solidFill>
-                        <a:srgbClr val="D4D1C6"/>
-                      </a:solidFill>
-                      <a:prstDash val="solid"/>
-                      <a:round/>
-                      <a:headEnd type="none" w="med" len="med"/>
-                      <a:tailEnd type="none" w="med" len="med"/>
-                    </a:lnL>
-                    <a:lnR w="12700" cap="flat" cmpd="sng" algn="ctr">
-                      <a:solidFill>
-                        <a:srgbClr val="D4D1C6"/>
-                      </a:solidFill>
-                      <a:prstDash val="solid"/>
-                      <a:round/>
-                      <a:headEnd type="none" w="med" len="med"/>
-                      <a:tailEnd type="none" w="med" len="med"/>
-                    </a:lnR>
-                    <a:lnT w="12700" cap="flat" cmpd="sng" algn="ctr">
-                      <a:solidFill>
-                        <a:srgbClr val="D4D1C6"/>
-                      </a:solidFill>
-                      <a:prstDash val="solid"/>
-                      <a:round/>
-                      <a:headEnd type="none" w="med" len="med"/>
-                      <a:tailEnd type="none" w="med" len="med"/>
-                    </a:lnT>
-                    <a:lnB w="12700" cap="flat" cmpd="sng" algn="ctr">
-                      <a:solidFill>
-                        <a:srgbClr val="D4D1C6"/>
-                      </a:solidFill>
-                      <a:prstDash val="solid"/>
-                      <a:round/>
-                      <a:headEnd type="none" w="med" len="med"/>
-                      <a:tailEnd type="none" w="med" len="med"/>
-                    </a:lnB>
                   </a:tcPr>
                 </a:tc>
                 <a:tc>
@@ -9961,6 +10912,9 @@
                       <a:headEnd type="none" w="med" len="med"/>
                       <a:tailEnd type="none" w="med" len="med"/>
                     </a:lnB>
+                    <a:solidFill>
+                      <a:srgbClr val="D1E4D6"/>
+                    </a:solidFill>
                   </a:tcPr>
                 </a:tc>
                 <a:tc>
@@ -9972,9 +10926,9 @@
                         <a:buNone/>
                       </a:pPr>
                       <a:r>
-                        <a:rPr lang="en-US" altLang="en-US" sz="1600" dirty="0">
+                        <a:rPr lang="en-US" altLang="en-US" sz="1600" b="1" dirty="0">
                           <a:solidFill>
-                            <a:srgbClr val="101C17"/>
+                            <a:srgbClr val="143D2A"/>
                           </a:solidFill>
                           <a:latin typeface="Inter" pitchFamily="34" charset="0"/>
                           <a:ea typeface="Inter" pitchFamily="34" charset="-122"/>
@@ -10026,6 +10980,9 @@
                       <a:headEnd type="none" w="med" len="med"/>
                       <a:tailEnd type="none" w="med" len="med"/>
                     </a:lnB>
+                    <a:solidFill>
+                      <a:srgbClr val="D1E4D6"/>
+                    </a:solidFill>
                   </a:tcPr>
                 </a:tc>
                 <a:tc>
@@ -10037,9 +10994,9 @@
                         <a:buNone/>
                       </a:pPr>
                       <a:r>
-                        <a:rPr lang="en-US" altLang="en-US" sz="1600" dirty="0">
+                        <a:rPr lang="en-US" altLang="en-US" sz="1600" b="1" dirty="0">
                           <a:solidFill>
-                            <a:srgbClr val="101C17"/>
+                            <a:srgbClr val="143D2A"/>
                           </a:solidFill>
                           <a:latin typeface="Inter" pitchFamily="34" charset="0"/>
                           <a:ea typeface="Inter" pitchFamily="34" charset="-122"/>
@@ -10091,136 +11048,9 @@
                       <a:headEnd type="none" w="med" len="med"/>
                       <a:tailEnd type="none" w="med" len="med"/>
                     </a:lnB>
-                  </a:tcPr>
-                </a:tc>
-                <a:tc>
-                  <a:txBody>
-                    <a:bodyPr/>
-                    <a:lstStyle/>
-                    <a:p>
-                      <a:pPr algn="ctr" indent="0" marL="0">
-                        <a:buNone/>
-                      </a:pPr>
-                      <a:r>
-                        <a:rPr lang="en-US" altLang="en-US" sz="1600" dirty="0">
-                          <a:solidFill>
-                            <a:srgbClr val="101C17"/>
-                          </a:solidFill>
-                          <a:latin typeface="Inter" pitchFamily="34" charset="0"/>
-                          <a:ea typeface="Inter" pitchFamily="34" charset="-122"/>
-                          <a:cs typeface="Inter" pitchFamily="34" charset="-120"/>
-                        </a:rPr>
-                        <a:t>Sim</a:t>
-                      </a:r>
-                      <a:endParaRPr lang="en-US" sz="1600" dirty="0">
-                        <a:latin typeface="Inter" charset="0"/>
-                        <a:ea typeface="Inter" charset="0"/>
-                        <a:cs typeface="Inter" charset="0"/>
-                      </a:endParaRPr>
-                    </a:p>
-                  </a:txBody>
-                  <a:tcPr marL="152400" marR="152400" marT="127000" marB="127000" anchor="ctr">
-                    <a:lnL w="12700" cap="flat" cmpd="sng" algn="ctr">
-                      <a:solidFill>
-                        <a:srgbClr val="D4D1C6"/>
-                      </a:solidFill>
-                      <a:prstDash val="solid"/>
-                      <a:round/>
-                      <a:headEnd type="none" w="med" len="med"/>
-                      <a:tailEnd type="none" w="med" len="med"/>
-                    </a:lnL>
-                    <a:lnR w="12700" cap="flat" cmpd="sng" algn="ctr">
-                      <a:solidFill>
-                        <a:srgbClr val="D4D1C6"/>
-                      </a:solidFill>
-                      <a:prstDash val="solid"/>
-                      <a:round/>
-                      <a:headEnd type="none" w="med" len="med"/>
-                      <a:tailEnd type="none" w="med" len="med"/>
-                    </a:lnR>
-                    <a:lnT w="12700" cap="flat" cmpd="sng" algn="ctr">
-                      <a:solidFill>
-                        <a:srgbClr val="D4D1C6"/>
-                      </a:solidFill>
-                      <a:prstDash val="solid"/>
-                      <a:round/>
-                      <a:headEnd type="none" w="med" len="med"/>
-                      <a:tailEnd type="none" w="med" len="med"/>
-                    </a:lnT>
-                    <a:lnB w="12700" cap="flat" cmpd="sng" algn="ctr">
-                      <a:solidFill>
-                        <a:srgbClr val="D4D1C6"/>
-                      </a:solidFill>
-                      <a:prstDash val="solid"/>
-                      <a:round/>
-                      <a:headEnd type="none" w="med" len="med"/>
-                      <a:tailEnd type="none" w="med" len="med"/>
-                    </a:lnB>
-                  </a:tcPr>
-                </a:tc>
-                <a:tc>
-                  <a:txBody>
-                    <a:bodyPr/>
-                    <a:lstStyle/>
-                    <a:p>
-                      <a:pPr algn="ctr" indent="0" marL="0">
-                        <a:buNone/>
-                      </a:pPr>
-                      <a:r>
-                        <a:rPr lang="en-US" altLang="en-US" sz="1600" dirty="0">
-                          <a:solidFill>
-                            <a:srgbClr val="101C17"/>
-                          </a:solidFill>
-                          <a:latin typeface="Inter" pitchFamily="34" charset="0"/>
-                          <a:ea typeface="Inter" pitchFamily="34" charset="-122"/>
-                          <a:cs typeface="Inter" pitchFamily="34" charset="-120"/>
-                        </a:rPr>
-                        <a:t>Sim</a:t>
-                      </a:r>
-                      <a:endParaRPr lang="en-US" sz="1600" dirty="0">
-                        <a:latin typeface="Inter" charset="0"/>
-                        <a:ea typeface="Inter" charset="0"/>
-                        <a:cs typeface="Inter" charset="0"/>
-                      </a:endParaRPr>
-                    </a:p>
-                  </a:txBody>
-                  <a:tcPr marL="152400" marR="152400" marT="127000" marB="127000" anchor="ctr">
-                    <a:lnL w="12700" cap="flat" cmpd="sng" algn="ctr">
-                      <a:solidFill>
-                        <a:srgbClr val="D4D1C6"/>
-                      </a:solidFill>
-                      <a:prstDash val="solid"/>
-                      <a:round/>
-                      <a:headEnd type="none" w="med" len="med"/>
-                      <a:tailEnd type="none" w="med" len="med"/>
-                    </a:lnL>
-                    <a:lnR w="12700" cap="flat" cmpd="sng" algn="ctr">
-                      <a:solidFill>
-                        <a:srgbClr val="D4D1C6"/>
-                      </a:solidFill>
-                      <a:prstDash val="solid"/>
-                      <a:round/>
-                      <a:headEnd type="none" w="med" len="med"/>
-                      <a:tailEnd type="none" w="med" len="med"/>
-                    </a:lnR>
-                    <a:lnT w="12700" cap="flat" cmpd="sng" algn="ctr">
-                      <a:solidFill>
-                        <a:srgbClr val="D4D1C6"/>
-                      </a:solidFill>
-                      <a:prstDash val="solid"/>
-                      <a:round/>
-                      <a:headEnd type="none" w="med" len="med"/>
-                      <a:tailEnd type="none" w="med" len="med"/>
-                    </a:lnT>
-                    <a:lnB w="12700" cap="flat" cmpd="sng" algn="ctr">
-                      <a:solidFill>
-                        <a:srgbClr val="D4D1C6"/>
-                      </a:solidFill>
-                      <a:prstDash val="solid"/>
-                      <a:round/>
-                      <a:headEnd type="none" w="med" len="med"/>
-                      <a:tailEnd type="none" w="med" len="med"/>
-                    </a:lnB>
+                    <a:solidFill>
+                      <a:srgbClr val="D1E4D6"/>
+                    </a:solidFill>
                   </a:tcPr>
                 </a:tc>
               </a:tr>
@@ -10319,6 +11149,45 @@
       <p:sp>
         <p:nvSpPr>
           <p:cNvPr id="10" name="permissoes-text-9"/>
+          <p:cNvSpPr/>
+          <p:nvPr/>
+        </p:nvSpPr>
+        <p:spPr>
+          <a:xfrm>
+            <a:off x="508000" y="2463800"/>
+            <a:ext cx="2032000" cy="177800"/>
+          </a:xfrm>
+          <a:prstGeom prst="rect">
+            <a:avLst/>
+          </a:prstGeom>
+          <a:noFill/>
+          <a:ln/>
+        </p:spPr>
+        <p:txBody>
+          <a:bodyPr wrap="none" lIns="0" tIns="0" rIns="0" bIns="0" rtlCol="0" anchor="t"/>
+          <a:lstStyle/>
+          <a:p>
+            <a:pPr algn="l" indent="0" marL="0">
+              <a:buNone/>
+            </a:pPr>
+            <a:r>
+              <a:rPr lang="en-US" altLang="en-US" sz="1100" dirty="0">
+                <a:solidFill>
+                  <a:srgbClr val="1C5D6C"/>
+                </a:solidFill>
+                <a:latin typeface="Inter" pitchFamily="34" charset="0"/>
+                <a:ea typeface="Inter" pitchFamily="34" charset="-122"/>
+                <a:cs typeface="Inter" pitchFamily="34" charset="-120"/>
+              </a:rPr>
+              <a:t>RBAC POR ORGANIZAÇÃO</a:t>
+            </a:r>
+            <a:endParaRPr lang="en-US" sz="1100" dirty="0"/>
+          </a:p>
+        </p:txBody>
+      </p:sp>
+      <p:sp>
+        <p:nvSpPr>
+          <p:cNvPr id="11" name="permissoes-text-10"/>
           <p:cNvSpPr/>
           <p:nvPr/>
         </p:nvSpPr>
@@ -10493,8 +11362,8 @@
         </p:nvSpPr>
         <p:spPr>
           <a:xfrm>
-            <a:off x="508000" y="2794000"/>
-            <a:ext cx="4572000" cy="4064000"/>
+            <a:off x="508000" y="2260600"/>
+            <a:ext cx="3111500" cy="330200"/>
           </a:xfrm>
           <a:prstGeom prst="rect">
             <a:avLst/>
@@ -10514,9 +11383,77 @@
           </a:ln>
         </p:spPr>
       </p:sp>
+      <p:sp>
+        <p:nvSpPr>
+          <p:cNvPr id="6" name="operacao-text-5"/>
+          <p:cNvSpPr/>
+          <p:nvPr/>
+        </p:nvSpPr>
+        <p:spPr>
+          <a:xfrm>
+            <a:off x="660400" y="2349500"/>
+            <a:ext cx="2794000" cy="152400"/>
+          </a:xfrm>
+          <a:prstGeom prst="rect">
+            <a:avLst/>
+          </a:prstGeom>
+          <a:noFill/>
+          <a:ln/>
+        </p:spPr>
+        <p:txBody>
+          <a:bodyPr wrap="none" lIns="0" tIns="0" rIns="0" bIns="0" rtlCol="0" anchor="t"/>
+          <a:lstStyle/>
+          <a:p>
+            <a:pPr algn="ctr" indent="0" marL="0">
+              <a:buNone/>
+            </a:pPr>
+            <a:r>
+              <a:rPr lang="en-US" altLang="en-US" sz="1100" dirty="0">
+                <a:solidFill>
+                  <a:srgbClr val="F9F8F4"/>
+                </a:solidFill>
+                <a:latin typeface="Inter" pitchFamily="34" charset="0"/>
+                <a:ea typeface="Inter" pitchFamily="34" charset="-122"/>
+                <a:cs typeface="Inter" pitchFamily="34" charset="-120"/>
+              </a:rPr>
+              <a:t>CHECKLIST DE PRÉ-PRODUÇÃO</a:t>
+            </a:r>
+            <a:endParaRPr lang="en-US" sz="1100" dirty="0"/>
+          </a:p>
+        </p:txBody>
+      </p:sp>
+      <p:sp>
+        <p:nvSpPr>
+          <p:cNvPr id="7" name="operacao-shape-6"/>
+          <p:cNvSpPr/>
+          <p:nvPr/>
+        </p:nvSpPr>
+        <p:spPr>
+          <a:xfrm>
+            <a:off x="508000" y="2794000"/>
+            <a:ext cx="4572000" cy="4064000"/>
+          </a:xfrm>
+          <a:prstGeom prst="rect">
+            <a:avLst/>
+          </a:prstGeom>
+          <a:solidFill>
+            <a:srgbClr val="F9F8F4">
+              <a:alpha val="8000"/>
+            </a:srgbClr>
+          </a:solidFill>
+          <a:ln w="12700">
+            <a:solidFill>
+              <a:srgbClr val="F9F8F4">
+                <a:alpha val="50000"/>
+              </a:srgbClr>
+            </a:solidFill>
+            <a:prstDash val="solid"/>
+          </a:ln>
+        </p:spPr>
+      </p:sp>
       <p:pic>
         <p:nvPicPr>
-          <p:cNvPr id="6" name="operacao-icon-5" descr="preencoded.png">    </p:cNvPr>
+          <p:cNvPr id="8" name="operacao-icon-7" descr="preencoded.png">    </p:cNvPr>
           <p:cNvPicPr>
             <a:picLocks noChangeAspect="1"/>
           </p:cNvPicPr>
@@ -10540,7 +11477,7 @@
       </p:pic>
       <p:sp>
         <p:nvSpPr>
-          <p:cNvPr id="7" name="operacao-text-6"/>
+          <p:cNvPr id="9" name="operacao-text-8"/>
           <p:cNvSpPr/>
           <p:nvPr/>
         </p:nvSpPr>
@@ -10596,7 +11533,7 @@
       </p:sp>
       <p:pic>
         <p:nvPicPr>
-          <p:cNvPr id="8" name="operacao-icon-7" descr="preencoded.png">    </p:cNvPr>
+          <p:cNvPr id="10" name="operacao-icon-9" descr="preencoded.png">    </p:cNvPr>
           <p:cNvPicPr>
             <a:picLocks noChangeAspect="1"/>
           </p:cNvPicPr>
@@ -10620,7 +11557,7 @@
       </p:pic>
       <p:sp>
         <p:nvSpPr>
-          <p:cNvPr id="9" name="operacao-text-8"/>
+          <p:cNvPr id="11" name="operacao-text-10"/>
           <p:cNvSpPr/>
           <p:nvPr/>
         </p:nvSpPr>
@@ -10676,7 +11613,7 @@
       </p:sp>
       <p:pic>
         <p:nvPicPr>
-          <p:cNvPr id="10" name="operacao-icon-9" descr="preencoded.png">    </p:cNvPr>
+          <p:cNvPr id="12" name="operacao-icon-11" descr="preencoded.png">    </p:cNvPr>
           <p:cNvPicPr>
             <a:picLocks noChangeAspect="1"/>
           </p:cNvPicPr>
@@ -10700,7 +11637,7 @@
       </p:pic>
       <p:sp>
         <p:nvSpPr>
-          <p:cNvPr id="11" name="operacao-text-10"/>
+          <p:cNvPr id="13" name="operacao-text-12"/>
           <p:cNvSpPr/>
           <p:nvPr/>
         </p:nvSpPr>
@@ -10756,7 +11693,7 @@
       </p:sp>
       <p:sp>
         <p:nvSpPr>
-          <p:cNvPr id="12" name="operacao-shape-11"/>
+          <p:cNvPr id="14" name="operacao-shape-13"/>
           <p:cNvSpPr/>
           <p:nvPr/>
         </p:nvSpPr>
@@ -10776,7 +11713,7 @@
       </p:sp>
       <p:sp>
         <p:nvSpPr>
-          <p:cNvPr id="13" name="operacao-text-12"/>
+          <p:cNvPr id="15" name="operacao-text-14"/>
           <p:cNvSpPr/>
           <p:nvPr/>
         </p:nvSpPr>
@@ -10815,7 +11752,7 @@
       </p:sp>
       <p:sp>
         <p:nvSpPr>
-          <p:cNvPr id="14" name="operacao-text-13"/>
+          <p:cNvPr id="16" name="operacao-text-15"/>
           <p:cNvSpPr/>
           <p:nvPr/>
         </p:nvSpPr>
@@ -10927,7 +11864,66 @@
       </p:sp>
       <p:sp>
         <p:nvSpPr>
-          <p:cNvPr id="15" name="operacao-shape-14"/>
+          <p:cNvPr id="17" name="operacao-shape-16"/>
+          <p:cNvSpPr/>
+          <p:nvPr/>
+        </p:nvSpPr>
+        <p:spPr>
+          <a:xfrm>
+            <a:off x="6223000" y="6273800"/>
+            <a:ext cx="7874000" cy="304800"/>
+          </a:xfrm>
+          <a:prstGeom prst="rect">
+            <a:avLst/>
+          </a:prstGeom>
+          <a:solidFill>
+            <a:srgbClr val="E2EEE6"/>
+          </a:solidFill>
+          <a:ln/>
+        </p:spPr>
+      </p:sp>
+      <p:sp>
+        <p:nvSpPr>
+          <p:cNvPr id="18" name="operacao-text-17"/>
+          <p:cNvSpPr/>
+          <p:nvPr/>
+        </p:nvSpPr>
+        <p:spPr>
+          <a:xfrm>
+            <a:off x="6350000" y="6350000"/>
+            <a:ext cx="7620000" cy="152400"/>
+          </a:xfrm>
+          <a:prstGeom prst="rect">
+            <a:avLst/>
+          </a:prstGeom>
+          <a:noFill/>
+          <a:ln/>
+        </p:spPr>
+        <p:txBody>
+          <a:bodyPr wrap="none" lIns="0" tIns="0" rIns="0" bIns="0" rtlCol="0" anchor="t"/>
+          <a:lstStyle/>
+          <a:p>
+            <a:pPr algn="ctr" indent="0" marL="0">
+              <a:buNone/>
+            </a:pPr>
+            <a:r>
+              <a:rPr lang="en-US" altLang="en-US" sz="1100" dirty="0">
+                <a:solidFill>
+                  <a:srgbClr val="143D2A"/>
+                </a:solidFill>
+                <a:latin typeface="Inter" pitchFamily="34" charset="0"/>
+                <a:ea typeface="Inter" pitchFamily="34" charset="-122"/>
+                <a:cs typeface="Inter" pitchFamily="34" charset="-120"/>
+              </a:rPr>
+              <a:t>RESULTADO: AMBIENTE VERIFICADO, RASTREÁVEL E PRONTO PARA HOMOLOGAÇÃO</a:t>
+            </a:r>
+            <a:endParaRPr lang="en-US" sz="1100" dirty="0"/>
+          </a:p>
+        </p:txBody>
+      </p:sp>
+      <p:sp>
+        <p:nvSpPr>
+          <p:cNvPr id="19" name="operacao-shape-18"/>
           <p:cNvSpPr/>
           <p:nvPr/>
         </p:nvSpPr>
@@ -10951,7 +11947,7 @@
       </p:sp>
       <p:sp>
         <p:nvSpPr>
-          <p:cNvPr id="16" name="operacao-text-15"/>
+          <p:cNvPr id="20" name="operacao-text-19"/>
           <p:cNvSpPr/>
           <p:nvPr/>
         </p:nvSpPr>
@@ -10990,7 +11986,7 @@
       </p:sp>
       <p:sp>
         <p:nvSpPr>
-          <p:cNvPr id="17" name="operacao-text-16"/>
+          <p:cNvPr id="21" name="operacao-text-20"/>
           <p:cNvSpPr/>
           <p:nvPr/>
         </p:nvSpPr>

</xml_diff>